<commit_message>
fix(diners): los dos objetivos del encargo vuelven al centro
Relanzamiento estrategico de marca y posicionamiento de beneficios son el
alcance contratado. La estrategia los habia reemplazado por tres frentes
propios y la propuesta no los mencionaba ni una vez.

- Estrategia: la seccion 4 se reorganiza bajo los dos objetivos; la aceptacion
  pasa de tercer frente a condicion que atraviesa los dos
- Propuesta web y PPT: los objetivos se declaran en la lamina del encargo y la
  lamina de capas pasa a 'Dos objetivos, tres capas', colgando cada capa de su
  objetivo

Co-Authored-By: Claude Opus 5 <noreply@anthropic.com>
</commit_message>
<xml_diff>
--- a/03 - Unidades de Negocio/Diners/Alianza-DCI/Plan-Medios-Colombia-DCI.pptx
+++ b/03 - Unidades de Negocio/Diners/Alianza-DCI/Plan-Medios-Colombia-DCI.pptx
@@ -10635,7 +10635,7 @@
                 </a:solidFill>
                 <a:latin typeface="Helvetica Neue"/>
               </a:rPr>
-              <a:t>El roadmap global de dining fija el calendario de los socios de LATAM. Esta propuesta es la entrega de Colombia, construida sobre las mejores prácticas que la franquicia ya validó en la región.</a:t>
+              <a:t>El encargo tiene dos objetivos: relanzamiento estratégico de marca y posicionamiento de beneficios. El roadmap global fija el calendario de los socios de LATAM, y esta propuesta es la entrega de Colombia.</a:t>
             </a:r>
           </a:p>
         </p:txBody>
@@ -14184,7 +14184,7 @@
                 </a:solidFill>
                 <a:latin typeface="Georgia"/>
               </a:rPr>
-              <a:t>Tres capas que se refuerzan</a:t>
+              <a:t>Dos objetivos, tres capas</a:t>
             </a:r>
           </a:p>
         </p:txBody>
@@ -14270,7 +14270,7 @@
                 </a:solidFill>
                 <a:latin typeface="Helvetica Neue"/>
               </a:rPr>
-              <a:t>Una entrega el beneficio, otra lo hace descubrible y la tercera construye estatus. El modelo sigue la lógica de portafolio que la franquicia ya opera en la región, donde conviven programas permanentes y campañas de temporada.</a:t>
+              <a:t>Relanzamiento estratégico de marca se sostiene en la capa editorial, que alcanza a quien todavía no es Clubmember. Posicionamiento de beneficios se sostiene en el beneficio recurrente y en las experiencias por invitación. La aceptación verificada es la condición que atraviesa los dos.</a:t>
             </a:r>
           </a:p>
         </p:txBody>

</xml_diff>

<commit_message>
feat(diners): la propuesta pasa a trimestre, independiente de la fecha de inicio
Doce semanas que arrancan con la firma, sin depender del mes del calendario.

- Campana: se quitan las fechas fijas, se agrupan los bloques por mes y se
  agrega la seccion de que queda construido al terminar el trimestre
- Propuesta web y PPT: la portada pasa de plan de medios anual a campana de
  posicionamiento Saber donde; los tres paquetes anuales se reemplazan por
  tres alcances del trimestre (Instalacion, Las doce semanas, Ampliada) y el
  comparativo se reconstruye sobre esos alcances

Razon de fondo: el presupuesto anual no esta confirmado y las acciones no
estan costeadas. Un trimestre se firma hoy y la decision del ano se toma con
datos de la semana 12.

Co-Authored-By: Claude Opus 5 <noreply@anthropic.com>
</commit_message>
<xml_diff>
--- a/03 - Unidades de Negocio/Diners/Alianza-DCI/Plan-Medios-Colombia-DCI.pptx
+++ b/03 - Unidades de Negocio/Diners/Alianza-DCI/Plan-Medios-Colombia-DCI.pptx
@@ -3378,9 +3378,9 @@
                 </a:solidFill>
                 <a:latin typeface="Georgia"/>
               </a:rPr>
-              <a:t>Colombia:
-plan de medios
-del Dining Program</a:t>
+              <a:t>Campaña de
+posicionamiento
+Saber dónde</a:t>
             </a:r>
           </a:p>
         </p:txBody>
@@ -3422,7 +3422,7 @@
                 </a:solidFill>
                 <a:latin typeface="Helvetica Neue"/>
               </a:rPr>
-              <a:t>Respuesta al roadmap global de dining. Adaptación local de las mejores prácticas de la franquicia, calendario de lanzamiento alineado al primer trimestre de 2027.</a:t>
+              <a:t>Doce semanas para relanzar la marca y posicionar sus beneficios ante quien todavía no es Clubmember. El plan corre desde la firma, sin depender del mes del calendario.</a:t>
             </a:r>
           </a:p>
         </p:txBody>
@@ -3896,7 +3896,7 @@
                 </a:solidFill>
                 <a:latin typeface="Helvetica Neue"/>
               </a:rPr>
-              <a:t>PARA LANZAMIENTO T1 2027</a:t>
+              <a:t>TRES MESES DESDE LA FIRMA</a:t>
             </a:r>
           </a:p>
         </p:txBody>
@@ -5430,7 +5430,7 @@
                 </a:solidFill>
                 <a:latin typeface="Helvetica Neue"/>
               </a:rPr>
-              <a:t>Seis mecanismos que hacen que una misma inversión produzca resultado en más de un frente. Están incorporados en los tres paquetes.</a:t>
+              <a:t>Seis mecanismos que hacen que una misma inversión produzca resultado en más de un frente. Están incorporados en las tres opciones.</a:t>
             </a:r>
           </a:p>
         </p:txBody>
@@ -6756,7 +6756,7 @@
                 </a:solidFill>
                 <a:latin typeface="Helvetica Neue"/>
               </a:rPr>
-              <a:t>LAS SEIS OPERAN EN LOS TRES PAQUETES</a:t>
+              <a:t>LAS SEIS OPERAN EN LAS TRES OPCIONES</a:t>
             </a:r>
           </a:p>
         </p:txBody>
@@ -6944,7 +6944,7 @@
                 </a:solidFill>
                 <a:latin typeface="Georgia"/>
               </a:rPr>
-              <a:t>Tres paquetes</a:t>
+              <a:t>Tres alcances para el trimestre</a:t>
             </a:r>
           </a:p>
         </p:txBody>
@@ -7030,7 +7030,7 @@
                 </a:solidFill>
                 <a:latin typeface="Helvetica Neue"/>
               </a:rPr>
-              <a:t>La misma estrategia, en tres tamaños. Todos incluyen la suscripción a la Revista Diners con 60% de beneficio exclusivo y código de activación.</a:t>
+              <a:t>La misma estrategia, en tres alcances. Las tres corren doce semanas desde la firma y las tres dejan medición de conversión a solicitud digital.</a:t>
             </a:r>
           </a:p>
         </p:txBody>
@@ -7118,7 +7118,7 @@
                 </a:solidFill>
                 <a:latin typeface="Helvetica Neue"/>
               </a:rPr>
-              <a:t>PAQUETE A</a:t>
+              <a:t>OPCIÓN A</a:t>
             </a:r>
           </a:p>
         </p:txBody>
@@ -7160,7 +7160,7 @@
                 </a:solidFill>
                 <a:latin typeface="Georgia"/>
               </a:rPr>
-              <a:t>Esencial</a:t>
+              <a:t>Instalación</a:t>
             </a:r>
           </a:p>
         </p:txBody>
@@ -7202,7 +7202,7 @@
                 </a:solidFill>
                 <a:latin typeface="Helvetica Neue"/>
               </a:rPr>
-              <a:t>Instalar la marca y probar el programa sin comprometer el año entero.</a:t>
+              <a:t>Solo el primer objetivo: instalar la marca ante quien no la tiene.</a:t>
             </a:r>
           </a:p>
         </p:txBody>
@@ -7244,7 +7244,7 @@
                 </a:solidFill>
                 <a:latin typeface="Helvetica Neue"/>
               </a:rPr>
-              <a:t>•  Pauta dinámica los 12 meses</a:t>
+              <a:t>•  Pauta dinámica los 3 meses</a:t>
             </a:r>
           </a:p>
           <a:p>
@@ -7263,7 +7263,7 @@
                 </a:solidFill>
                 <a:latin typeface="Helvetica Neue"/>
               </a:rPr>
-              <a:t>•  Una pieza de alto impacto de lanzamiento</a:t>
+              <a:t>•  Una pieza de alto impacto de apertura</a:t>
             </a:r>
           </a:p>
           <a:p>
@@ -7282,7 +7282,7 @@
                 </a:solidFill>
                 <a:latin typeface="Helvetica Neue"/>
               </a:rPr>
-              <a:t>•  Mesa Diners Club en 20 aliados, Bogotá</a:t>
+              <a:t>•  Video manifiesto y su amplificación</a:t>
             </a:r>
           </a:p>
           <a:p>
@@ -7301,7 +7301,7 @@
                 </a:solidFill>
                 <a:latin typeface="Helvetica Neue"/>
               </a:rPr>
-              <a:t>•  2 experiencias OBI</a:t>
+              <a:t>•  Sección editorial en la revista</a:t>
             </a:r>
           </a:p>
           <a:p>
@@ -7494,7 +7494,7 @@
                 </a:solidFill>
                 <a:latin typeface="Helvetica Neue"/>
               </a:rPr>
-              <a:t>PAQUETE B</a:t>
+              <a:t>OPCIÓN B</a:t>
             </a:r>
           </a:p>
         </p:txBody>
@@ -7536,7 +7536,7 @@
                 </a:solidFill>
                 <a:latin typeface="Georgia"/>
               </a:rPr>
-              <a:t>Completo</a:t>
+              <a:t>Las doce semanas</a:t>
             </a:r>
           </a:p>
         </p:txBody>
@@ -7578,7 +7578,7 @@
                 </a:solidFill>
                 <a:latin typeface="Helvetica Neue"/>
               </a:rPr>
-              <a:t>El año completo con las tres capas operando y dato propio a escala.</a:t>
+              <a:t>Los dos objetivos operando y el primer dato propio de conversión.</a:t>
             </a:r>
           </a:p>
         </p:txBody>
@@ -7620,7 +7620,7 @@
                 </a:solidFill>
                 <a:latin typeface="Helvetica Neue"/>
               </a:rPr>
-              <a:t>•  59 piezas en medios propios: Diners y AXXIS</a:t>
+              <a:t>•  Todo lo de la opción A</a:t>
             </a:r>
           </a:p>
           <a:p>
@@ -7639,7 +7639,7 @@
                 </a:solidFill>
                 <a:latin typeface="Helvetica Neue"/>
               </a:rPr>
-              <a:t>•  20 campañas digitales en 5 canales</a:t>
+              <a:t>•  20 aliados con aceptación verificada</a:t>
             </a:r>
           </a:p>
           <a:p>
@@ -7658,7 +7658,7 @@
                 </a:solidFill>
                 <a:latin typeface="Helvetica Neue"/>
               </a:rPr>
-              <a:t>•  Alto impacto: portada falsa, carnet, gatefold</a:t>
+              <a:t>•  Sello en punto de venta con código</a:t>
             </a:r>
           </a:p>
           <a:p>
@@ -7677,7 +7677,7 @@
                 </a:solidFill>
                 <a:latin typeface="Helvetica Neue"/>
               </a:rPr>
-              <a:t>•  Mesa Diners Club en 40 aliados, Bogotá</a:t>
+              <a:t>•  Una experiencia por invitación, con cubrimiento</a:t>
             </a:r>
           </a:p>
           <a:p>
@@ -7696,7 +7696,7 @@
                 </a:solidFill>
                 <a:latin typeface="Helvetica Neue"/>
               </a:rPr>
-              <a:t>•  La Mesa Diners en los tres soportes</a:t>
+              <a:t>•  Pauta digital en 4 canales</a:t>
             </a:r>
           </a:p>
           <a:p>
@@ -7715,7 +7715,7 @@
                 </a:solidFill>
                 <a:latin typeface="Helvetica Neue"/>
               </a:rPr>
-              <a:t>•  6 experiencias OBI</a:t>
+              <a:t>•  Serie de video con cocineros</a:t>
             </a:r>
           </a:p>
           <a:p>
@@ -7734,7 +7734,7 @@
                 </a:solidFill>
                 <a:latin typeface="Helvetica Neue"/>
               </a:rPr>
-              <a:t>•  Tablero de cohortes e informe de año</a:t>
+              <a:t>•  Tablero de conversión a solicitud digital</a:t>
             </a:r>
           </a:p>
         </p:txBody>
@@ -7822,7 +7822,7 @@
                 </a:solidFill>
                 <a:latin typeface="Helvetica Neue"/>
               </a:rPr>
-              <a:t>PAQUETE C</a:t>
+              <a:t>OPCIÓN C</a:t>
             </a:r>
           </a:p>
         </p:txBody>
@@ -7864,7 +7864,7 @@
                 </a:solidFill>
                 <a:latin typeface="Georgia"/>
               </a:rPr>
-              <a:t>Insignia</a:t>
+              <a:t>Ampliada</a:t>
             </a:r>
           </a:p>
         </p:txBody>
@@ -7906,7 +7906,7 @@
                 </a:solidFill>
                 <a:latin typeface="Helvetica Neue"/>
               </a:rPr>
-              <a:t>El año completo más un activo editorial que sobrevive a la campaña.</a:t>
+              <a:t>Las doce semanas con mayor cobertura de audiencia y de red.</a:t>
             </a:r>
           </a:p>
         </p:txBody>
@@ -7948,7 +7948,7 @@
                 </a:solidFill>
                 <a:latin typeface="Helvetica Neue"/>
               </a:rPr>
-              <a:t>•  Todo lo del Paquete B</a:t>
+              <a:t>•  Todo lo de la opción B</a:t>
             </a:r>
           </a:p>
           <a:p>
@@ -7967,7 +7967,7 @@
                 </a:solidFill>
                 <a:latin typeface="Helvetica Neue"/>
               </a:rPr>
-              <a:t>•  Línea de video con personaje</a:t>
+              <a:t>•  AXXIS sumado al ecosistema</a:t>
             </a:r>
           </a:p>
           <a:p>
@@ -7986,7 +7986,7 @@
                 </a:solidFill>
                 <a:latin typeface="Helvetica Neue"/>
               </a:rPr>
-              <a:t>•  Evento insignia anual con los aliados</a:t>
+              <a:t>•  40 aliados verificados</a:t>
             </a:r>
           </a:p>
           <a:p>
@@ -8005,7 +8005,7 @@
                 </a:solidFill>
                 <a:latin typeface="Helvetica Neue"/>
               </a:rPr>
-              <a:t>•  8 OBI y apertura a una segunda ciudad</a:t>
+              <a:t>•  Dos experiencias por invitación</a:t>
             </a:r>
           </a:p>
           <a:p>
@@ -8024,7 +8024,7 @@
                 </a:solidFill>
                 <a:latin typeface="Helvetica Neue"/>
               </a:rPr>
-              <a:t>•  Compendio coleccionable de fin de año</a:t>
+              <a:t>•  Línea de video con personaje invitado</a:t>
             </a:r>
           </a:p>
           <a:p>
@@ -8043,7 +8043,7 @@
                 </a:solidFill>
                 <a:latin typeface="Helvetica Neue"/>
               </a:rPr>
-              <a:t>•  Base para el premio gastronómico colombiano</a:t>
+              <a:t>•  LinkedIn y programática para el perfil alto</a:t>
             </a:r>
           </a:p>
         </p:txBody>
@@ -8273,7 +8273,7 @@
                 </a:solidFill>
                 <a:latin typeface="Georgia"/>
               </a:rPr>
-              <a:t>Qué incluye cada paquete</a:t>
+              <a:t>Qué incluye cada opción</a:t>
             </a:r>
           </a:p>
         </p:txBody>
@@ -8332,7 +8332,7 @@
         </p:nvGraphicFramePr>
         <p:xfrm>
           <a:off x="731520" y="2103120"/>
-          <a:ext cx="10725912" cy="3374136"/>
+          <a:ext cx="10725912" cy="3749040"/>
         </p:xfrm>
         <a:graphic>
           <a:graphicData uri="http://schemas.openxmlformats.org/drawingml/2006/table">
@@ -8381,7 +8381,7 @@
                           </a:solidFill>
                           <a:latin typeface="Helvetica Neue"/>
                         </a:rPr>
-                        <a:t>A · Esencial</a:t>
+                        <a:t>A · Instalación</a:t>
                       </a:r>
                     </a:p>
                   </a:txBody>
@@ -8403,7 +8403,7 @@
                           </a:solidFill>
                           <a:latin typeface="Helvetica Neue"/>
                         </a:rPr>
-                        <a:t>B · Completo</a:t>
+                        <a:t>B · Las doce semanas</a:t>
                       </a:r>
                     </a:p>
                   </a:txBody>
@@ -8425,7 +8425,7 @@
                           </a:solidFill>
                           <a:latin typeface="Helvetica Neue"/>
                         </a:rPr>
-                        <a:t>C · Insignia</a:t>
+                        <a:t>C · Ampliada</a:t>
                       </a:r>
                     </a:p>
                   </a:txBody>
@@ -8449,7 +8449,7 @@
                           </a:solidFill>
                           <a:latin typeface="Georgia"/>
                         </a:rPr>
-                        <a:t>Medios propios</a:t>
+                        <a:t>Duración</a:t>
                       </a:r>
                     </a:p>
                   </a:txBody>
@@ -8471,7 +8471,7 @@
                           </a:solidFill>
                           <a:latin typeface="Georgia"/>
                         </a:rPr>
-                        <a:t>Pauta dinámica + 1 alto impacto</a:t>
+                        <a:t>12 semanas</a:t>
                       </a:r>
                     </a:p>
                   </a:txBody>
@@ -8493,7 +8493,7 @@
                           </a:solidFill>
                           <a:latin typeface="Georgia"/>
                         </a:rPr>
-                        <a:t>59 piezas</a:t>
+                        <a:t>12 semanas</a:t>
                       </a:r>
                     </a:p>
                   </a:txBody>
@@ -8515,7 +8515,7 @@
                           </a:solidFill>
                           <a:latin typeface="Georgia"/>
                         </a:rPr>
-                        <a:t>59 piezas + evento insignia</a:t>
+                        <a:t>12 semanas</a:t>
                       </a:r>
                     </a:p>
                   </a:txBody>
@@ -8583,7 +8583,7 @@
                           </a:solidFill>
                           <a:latin typeface="Georgia"/>
                         </a:rPr>
-                        <a:t>Diners + AXXIS</a:t>
+                        <a:t>Solo Diners</a:t>
                       </a:r>
                     </a:p>
                   </a:txBody>
@@ -8629,7 +8629,187 @@
                           </a:solidFill>
                           <a:latin typeface="Georgia"/>
                         </a:rPr>
+                        <a:t>Alto impacto impreso</a:t>
+                      </a:r>
+                    </a:p>
+                  </a:txBody>
+                  <a:tcPr marL="73152" marR="45720" anchor="ctr">
+                    <a:solidFill>
+                      <a:srgbClr val="FFFDF9"/>
+                    </a:solidFill>
+                  </a:tcPr>
+                </a:tc>
+                <a:tc>
+                  <a:txBody>
+                    <a:bodyPr/>
+                    <a:lstStyle/>
+                    <a:p>
+                      <a:r>
+                        <a:rPr sz="900" b="0">
+                          <a:solidFill>
+                            <a:srgbClr val="0A2540"/>
+                          </a:solidFill>
+                          <a:latin typeface="Georgia"/>
+                        </a:rPr>
+                        <a:t>1 pieza</a:t>
+                      </a:r>
+                    </a:p>
+                  </a:txBody>
+                  <a:tcPr marL="73152" marR="45720" anchor="ctr">
+                    <a:solidFill>
+                      <a:srgbClr val="FFFDF9"/>
+                    </a:solidFill>
+                  </a:tcPr>
+                </a:tc>
+                <a:tc>
+                  <a:txBody>
+                    <a:bodyPr/>
+                    <a:lstStyle/>
+                    <a:p>
+                      <a:r>
+                        <a:rPr sz="900" b="1">
+                          <a:solidFill>
+                            <a:srgbClr val="0A2540"/>
+                          </a:solidFill>
+                          <a:latin typeface="Georgia"/>
+                        </a:rPr>
+                        <a:t>1 pieza</a:t>
+                      </a:r>
+                    </a:p>
+                  </a:txBody>
+                  <a:tcPr marL="73152" marR="45720" anchor="ctr">
+                    <a:solidFill>
+                      <a:srgbClr val="F4EAD5"/>
+                    </a:solidFill>
+                  </a:tcPr>
+                </a:tc>
+                <a:tc>
+                  <a:txBody>
+                    <a:bodyPr/>
+                    <a:lstStyle/>
+                    <a:p>
+                      <a:r>
+                        <a:rPr sz="900" b="0">
+                          <a:solidFill>
+                            <a:srgbClr val="0A2540"/>
+                          </a:solidFill>
+                          <a:latin typeface="Georgia"/>
+                        </a:rPr>
+                        <a:t>2 piezas</a:t>
+                      </a:r>
+                    </a:p>
+                  </a:txBody>
+                  <a:tcPr marL="73152" marR="45720" anchor="ctr">
+                    <a:solidFill>
+                      <a:srgbClr val="FFFDF9"/>
+                    </a:solidFill>
+                  </a:tcPr>
+                </a:tc>
+              </a:tr>
+              <a:tr h="374904">
+                <a:tc>
+                  <a:txBody>
+                    <a:bodyPr/>
+                    <a:lstStyle/>
+                    <a:p>
+                      <a:r>
+                        <a:rPr sz="900" b="1">
+                          <a:solidFill>
+                            <a:srgbClr val="0A2540"/>
+                          </a:solidFill>
+                          <a:latin typeface="Georgia"/>
+                        </a:rPr>
                         <a:t>Pauta digital</a:t>
+                      </a:r>
+                    </a:p>
+                  </a:txBody>
+                  <a:tcPr marL="73152" marR="45720" anchor="ctr">
+                    <a:solidFill>
+                      <a:srgbClr val="F6F3EC"/>
+                    </a:solidFill>
+                  </a:tcPr>
+                </a:tc>
+                <a:tc>
+                  <a:txBody>
+                    <a:bodyPr/>
+                    <a:lstStyle/>
+                    <a:p>
+                      <a:r>
+                        <a:rPr sz="900" b="0">
+                          <a:solidFill>
+                            <a:srgbClr val="0A2540"/>
+                          </a:solidFill>
+                          <a:latin typeface="Georgia"/>
+                        </a:rPr>
+                        <a:t>—</a:t>
+                      </a:r>
+                    </a:p>
+                  </a:txBody>
+                  <a:tcPr marL="73152" marR="45720" anchor="ctr">
+                    <a:solidFill>
+                      <a:srgbClr val="F6F3EC"/>
+                    </a:solidFill>
+                  </a:tcPr>
+                </a:tc>
+                <a:tc>
+                  <a:txBody>
+                    <a:bodyPr/>
+                    <a:lstStyle/>
+                    <a:p>
+                      <a:r>
+                        <a:rPr sz="900" b="1">
+                          <a:solidFill>
+                            <a:srgbClr val="0A2540"/>
+                          </a:solidFill>
+                          <a:latin typeface="Georgia"/>
+                        </a:rPr>
+                        <a:t>4 canales</a:t>
+                      </a:r>
+                    </a:p>
+                  </a:txBody>
+                  <a:tcPr marL="73152" marR="45720" anchor="ctr">
+                    <a:solidFill>
+                      <a:srgbClr val="F4EAD5"/>
+                    </a:solidFill>
+                  </a:tcPr>
+                </a:tc>
+                <a:tc>
+                  <a:txBody>
+                    <a:bodyPr/>
+                    <a:lstStyle/>
+                    <a:p>
+                      <a:r>
+                        <a:rPr sz="900" b="0">
+                          <a:solidFill>
+                            <a:srgbClr val="0A2540"/>
+                          </a:solidFill>
+                          <a:latin typeface="Georgia"/>
+                        </a:rPr>
+                        <a:t>6 canales</a:t>
+                      </a:r>
+                    </a:p>
+                  </a:txBody>
+                  <a:tcPr marL="73152" marR="45720" anchor="ctr">
+                    <a:solidFill>
+                      <a:srgbClr val="F6F3EC"/>
+                    </a:solidFill>
+                  </a:tcPr>
+                </a:tc>
+              </a:tr>
+              <a:tr h="374904">
+                <a:tc>
+                  <a:txBody>
+                    <a:bodyPr/>
+                    <a:lstStyle/>
+                    <a:p>
+                      <a:r>
+                        <a:rPr sz="900" b="1">
+                          <a:solidFill>
+                            <a:srgbClr val="0A2540"/>
+                          </a:solidFill>
+                          <a:latin typeface="Georgia"/>
+                        </a:rPr>
+                        <a:t>Aliados verificados</a:t>
                       </a:r>
                     </a:p>
                   </a:txBody>
@@ -8673,7 +8853,7 @@
                           </a:solidFill>
                           <a:latin typeface="Georgia"/>
                         </a:rPr>
-                        <a:t>20 campañas, 5 canales</a:t>
+                        <a:t>20</a:t>
                       </a:r>
                     </a:p>
                   </a:txBody>
@@ -8695,7 +8875,7 @@
                           </a:solidFill>
                           <a:latin typeface="Georgia"/>
                         </a:rPr>
-                        <a:t>20 campañas, 5 canales</a:t>
+                        <a:t>40</a:t>
                       </a:r>
                     </a:p>
                   </a:txBody>
@@ -8719,7 +8899,7 @@
                           </a:solidFill>
                           <a:latin typeface="Georgia"/>
                         </a:rPr>
-                        <a:t>Mesa Diners Club</a:t>
+                        <a:t>Sello en punto de venta</a:t>
                       </a:r>
                     </a:p>
                   </a:txBody>
@@ -8741,7 +8921,7 @@
                           </a:solidFill>
                           <a:latin typeface="Georgia"/>
                         </a:rPr>
-                        <a:t>20 aliados, Bogotá</a:t>
+                        <a:t>—</a:t>
                       </a:r>
                     </a:p>
                   </a:txBody>
@@ -8763,7 +8943,7 @@
                           </a:solidFill>
                           <a:latin typeface="Georgia"/>
                         </a:rPr>
-                        <a:t>40 aliados, Bogotá</a:t>
+                        <a:t>Sí</a:t>
                       </a:r>
                     </a:p>
                   </a:txBody>
@@ -8785,7 +8965,7 @@
                           </a:solidFill>
                           <a:latin typeface="Georgia"/>
                         </a:rPr>
-                        <a:t>40 aliados + 2a ciudad</a:t>
+                        <a:t>Sí</a:t>
                       </a:r>
                     </a:p>
                   </a:txBody>
@@ -8809,7 +8989,7 @@
                           </a:solidFill>
                           <a:latin typeface="Georgia"/>
                         </a:rPr>
-                        <a:t>La Mesa Diners</a:t>
+                        <a:t>Experiencias por invitación</a:t>
                       </a:r>
                     </a:p>
                   </a:txBody>
@@ -8831,7 +9011,7 @@
                           </a:solidFill>
                           <a:latin typeface="Georgia"/>
                         </a:rPr>
-                        <a:t>Sección mensual</a:t>
+                        <a:t>—</a:t>
                       </a:r>
                     </a:p>
                   </a:txBody>
@@ -8853,7 +9033,7 @@
                           </a:solidFill>
                           <a:latin typeface="Georgia"/>
                         </a:rPr>
-                        <a:t>Sección, web y video</a:t>
+                        <a:t>1</a:t>
                       </a:r>
                     </a:p>
                   </a:txBody>
@@ -8875,7 +9055,7 @@
                           </a:solidFill>
                           <a:latin typeface="Georgia"/>
                         </a:rPr>
-                        <a:t>Sección, web, video y compendio</a:t>
+                        <a:t>2</a:t>
                       </a:r>
                     </a:p>
                   </a:txBody>
@@ -8899,7 +9079,7 @@
                           </a:solidFill>
                           <a:latin typeface="Georgia"/>
                         </a:rPr>
-                        <a:t>Experiencias OBI</a:t>
+                        <a:t>Video</a:t>
                       </a:r>
                     </a:p>
                   </a:txBody>
@@ -8921,7 +9101,7 @@
                           </a:solidFill>
                           <a:latin typeface="Georgia"/>
                         </a:rPr>
-                        <a:t>2</a:t>
+                        <a:t>Manifiesto</a:t>
                       </a:r>
                     </a:p>
                   </a:txBody>
@@ -8943,7 +9123,7 @@
                           </a:solidFill>
                           <a:latin typeface="Georgia"/>
                         </a:rPr>
-                        <a:t>6</a:t>
+                        <a:t>Manifiesto + cocineros</a:t>
                       </a:r>
                     </a:p>
                   </a:txBody>
@@ -8965,7 +9145,7 @@
                           </a:solidFill>
                           <a:latin typeface="Georgia"/>
                         </a:rPr>
-                        <a:t>8</a:t>
+                        <a:t>+ personaje invitado</a:t>
                       </a:r>
                     </a:p>
                   </a:txBody>
@@ -8989,7 +9169,7 @@
                           </a:solidFill>
                           <a:latin typeface="Georgia"/>
                         </a:rPr>
-                        <a:t>Alcance a prospectos</a:t>
+                        <a:t>Medición de solicitudes</a:t>
                       </a:r>
                     </a:p>
                   </a:txBody>
@@ -9011,7 +9191,7 @@
                           </a:solidFill>
                           <a:latin typeface="Georgia"/>
                         </a:rPr>
-                        <a:t>Sí</a:t>
+                        <a:t>Parcial</a:t>
                       </a:r>
                     </a:p>
                   </a:txBody>
@@ -9033,7 +9213,7 @@
                           </a:solidFill>
                           <a:latin typeface="Georgia"/>
                         </a:rPr>
-                        <a:t>Sí, a escala</a:t>
+                        <a:t>Completa</a:t>
                       </a:r>
                     </a:p>
                   </a:txBody>
@@ -9055,7 +9235,7 @@
                           </a:solidFill>
                           <a:latin typeface="Georgia"/>
                         </a:rPr>
-                        <a:t>Sí, a escala</a:t>
+                        <a:t>Completa</a:t>
                       </a:r>
                     </a:p>
                   </a:txBody>
@@ -9066,96 +9246,6 @@
                   </a:tcPr>
                 </a:tc>
               </a:tr>
-              <a:tr h="374904">
-                <a:tc>
-                  <a:txBody>
-                    <a:bodyPr/>
-                    <a:lstStyle/>
-                    <a:p>
-                      <a:r>
-                        <a:rPr sz="900" b="1">
-                          <a:solidFill>
-                            <a:srgbClr val="0A2540"/>
-                          </a:solidFill>
-                          <a:latin typeface="Georgia"/>
-                        </a:rPr>
-                        <a:t>Catálogo listo para la app</a:t>
-                      </a:r>
-                    </a:p>
-                  </a:txBody>
-                  <a:tcPr marL="73152" marR="45720" anchor="ctr">
-                    <a:solidFill>
-                      <a:srgbClr val="F6F3EC"/>
-                    </a:solidFill>
-                  </a:tcPr>
-                </a:tc>
-                <a:tc>
-                  <a:txBody>
-                    <a:bodyPr/>
-                    <a:lstStyle/>
-                    <a:p>
-                      <a:r>
-                        <a:rPr sz="900" b="0">
-                          <a:solidFill>
-                            <a:srgbClr val="0A2540"/>
-                          </a:solidFill>
-                          <a:latin typeface="Georgia"/>
-                        </a:rPr>
-                        <a:t>Parcial</a:t>
-                      </a:r>
-                    </a:p>
-                  </a:txBody>
-                  <a:tcPr marL="73152" marR="45720" anchor="ctr">
-                    <a:solidFill>
-                      <a:srgbClr val="F6F3EC"/>
-                    </a:solidFill>
-                  </a:tcPr>
-                </a:tc>
-                <a:tc>
-                  <a:txBody>
-                    <a:bodyPr/>
-                    <a:lstStyle/>
-                    <a:p>
-                      <a:r>
-                        <a:rPr sz="900" b="1">
-                          <a:solidFill>
-                            <a:srgbClr val="0A2540"/>
-                          </a:solidFill>
-                          <a:latin typeface="Georgia"/>
-                        </a:rPr>
-                        <a:t>Completo</a:t>
-                      </a:r>
-                    </a:p>
-                  </a:txBody>
-                  <a:tcPr marL="73152" marR="45720" anchor="ctr">
-                    <a:solidFill>
-                      <a:srgbClr val="F4EAD5"/>
-                    </a:solidFill>
-                  </a:tcPr>
-                </a:tc>
-                <a:tc>
-                  <a:txBody>
-                    <a:bodyPr/>
-                    <a:lstStyle/>
-                    <a:p>
-                      <a:r>
-                        <a:rPr sz="900" b="0">
-                          <a:solidFill>
-                            <a:srgbClr val="0A2540"/>
-                          </a:solidFill>
-                          <a:latin typeface="Georgia"/>
-                        </a:rPr>
-                        <a:t>Completo</a:t>
-                      </a:r>
-                    </a:p>
-                  </a:txBody>
-                  <a:tcPr marL="73152" marR="45720" anchor="ctr">
-                    <a:solidFill>
-                      <a:srgbClr val="F6F3EC"/>
-                    </a:solidFill>
-                  </a:tcPr>
-                </a:tc>
-              </a:tr>
             </a:tbl>
           </a:graphicData>
         </a:graphic>
@@ -9243,7 +9333,7 @@
                 </a:solidFill>
                 <a:latin typeface="Helvetica Neue"/>
               </a:rPr>
-              <a:t>POR QUÉ RECOMENDAMOS EL PAQUETE B</a:t>
+              <a:t>POR QUÉ RECOMENDAMOS LA OPCIÓN B</a:t>
             </a:r>
           </a:p>
         </p:txBody>
@@ -9285,7 +9375,7 @@
                 </a:solidFill>
                 <a:latin typeface="Helvetica Neue"/>
               </a:rPr>
-              <a:t>Es el único que cubre los dos públicos y genera volumen de registro suficiente para leer resultados por cohorte. Con el A se valida la mecánica; con el B se decide el año siguiente con datos propios.</a:t>
+              <a:t>Es el alcance mínimo que activa los dos objetivos y deja medición de punta a punta. La opción A instala marca sin construir la red; la C amplía cobertura cuando el presupuesto lo permita.</a:t>
             </a:r>
           </a:p>
         </p:txBody>
@@ -10635,7 +10725,7 @@
                 </a:solidFill>
                 <a:latin typeface="Helvetica Neue"/>
               </a:rPr>
-              <a:t>El encargo tiene dos objetivos: relanzamiento estratégico de marca y posicionamiento de beneficios. El roadmap global fija el calendario de los socios de LATAM, y esta propuesta es la entrega de Colombia.</a:t>
+              <a:t>El encargo tiene dos objetivos: relanzamiento estratégico de marca y posicionamiento de beneficios. Esta propuesta cubre el primer trimestre, construida sobre las mejores prácticas de la franquicia y sobre el roadmap global.</a:t>
             </a:r>
           </a:p>
         </p:txBody>

</xml_diff>